<commit_message>
Submission evidence: paid collection proof, live runs of all 4 cards, demo reel, rebuilt deck
Claude-Session: https://claude.ai/code/session_01Fq1Zos7UvkVkVgbaKd2nxx
</commit_message>
<xml_diff>
--- a/docs/deck/PersonaLab.pptx
+++ b/docs/deck/PersonaLab.pptx
@@ -513,7 +513,7 @@
           <a:lstStyle/>
           <a:p>
             <a:r>
-              <a:t>[0:00-0:10] PersonaLab is a Sokosumi Coworker that launches and grows an original AI influencer. Four ready-to-run tasks: Create, Script, Trends and Analyze, each paid per task through Masumi on Cardano.</a:t>
+              <a:t>[0:00-0:10] PersonaLab is a Sokosumi Coworker that launches and grows an original AI influencer. Four ready-to-run tasks: Onboarding, Create, Script and Trends, each paid per task through Masumi on Cardano.</a:t>
             </a:r>
           </a:p>
         </p:txBody>
@@ -588,7 +588,7 @@
           </a:p>
           <a:p>
             <a:r>
-              <a:t>The biggest scope change: Sokosumi cannot link Instagram or TikTok accounts, so Schedule and Engage were taken off the card list.</a:t>
+              <a:t>The biggest scope change: Sokosumi cannot link Instagram or TikTok accounts, so Schedule, Engage and Analyze were taken off the card list.</a:t>
             </a:r>
           </a:p>
         </p:txBody>
@@ -663,7 +663,7 @@
           </a:p>
           <a:p>
             <a:r>
-              <a:t>After that: video reels and voice, human approval through LangGraph interrupts, each stage as its own hireable Masumi agent, and a hosted deployment.</a:t>
+              <a:t>After that: human approval through LangGraph interrupts, each stage as its own hireable Masumi agent, and a hosted deployment (today everything runs on the operator machine).</a:t>
             </a:r>
           </a:p>
         </p:txBody>
@@ -888,22 +888,27 @@
           </a:p>
           <a:p>
             <a:r>
-              <a:t>Create builds the persona, photos with an image model, a reel script and a 7-day plan.</a:t>
-            </a:r>
-          </a:p>
-          <a:p>
-            <a:r>
-              <a:t>Script writes trend-based Reels and TikTok scripts. Trends runs a swarm of parallel research agents and cites its evidence.</a:t>
-            </a:r>
-          </a:p>
-          <a:p>
-            <a:r>
-              <a:t>Analyze turns pasted metrics into KPIs, hook scores and next week's plan.</a:t>
-            </a:r>
-          </a:p>
-          <a:p>
-            <a:r>
-              <a:t>Schedule and Engage exist in code in dry-run mode but are not offered, because Sokosumi cannot link Instagram or TikTok accounts yet.</a:t>
+              <a:t>Onboarding builds a personal virtual avatar of a real creator from their interests, values, story and moat, plus a reusable Avatar JSON.</a:t>
+            </a:r>
+          </a:p>
+          <a:p>
+            <a:r>
+              <a:t>Create runs the trend swarm, designs the persona, writes a scene script citing the trend URL, renders persona-consistent keyframes</a:t>
+            </a:r>
+          </a:p>
+          <a:p>
+            <a:r>
+              <a:t>(Gemini 3.1 Flash Lite Image), animates them with xAI Grok Imagine Video 1.5 Lite, adds voiceover and outputs a 9:16 MP4 (ffmpeg fallback).</a:t>
+            </a:r>
+          </a:p>
+          <a:p>
+            <a:r>
+              <a:t>Script writes trend-based Reels and TikTok scripts. Trends runs a swarm of parallel research agents and keeps only cited evidence.</a:t>
+            </a:r>
+          </a:p>
+          <a:p>
+            <a:r>
+              <a:t>Schedule, Engage and Analyze exist in code (Instagram API dry-run) but are not offered, because Sokosumi cannot link Instagram or TikTok accounts.</a:t>
             </a:r>
           </a:p>
         </p:txBody>
@@ -994,7 +999,7 @@
           </a:p>
           <a:p>
             <a:r>
-              <a:t>  "PersonaLab is a Sokosumi Coworker that runs an AI influencer: Create, Script, Trends, Analyze."</a:t>
+              <a:t>  "PersonaLab is a Sokosumi Coworker that runs an AI influencer: Onboarding, Create, Script, Trends."</a:t>
             </a:r>
           </a:p>
           <a:p>
@@ -1029,7 +1034,7 @@
           </a:p>
           <a:p>
             <a:r>
-              <a:t>[0:50-1:05] Task COMPLETED. Scroll the result: ranked trends, each with cited sources, then a Script run that uses them.</a:t>
+              <a:t>[0:50-1:05] Task COMPLETED. Scroll the result: ranked trends, each with cited sources, then the Create reel (9:16 MP4) built on one trend.</a:t>
             </a:r>
           </a:p>
           <a:p>
@@ -1039,7 +1044,7 @@
           </a:p>
           <a:p>
             <a:r>
-              <a:t>[1:05-1:20] Payment: MPS terms, escrow FundsLocked on preprod.cardanoscan.io, result hash, collection (when done).</a:t>
+              <a:t>[1:05-1:20] Payment: MPS terms, escrow FundsLocked, ResultSubmitted and Withdrawn on preprod.cardanoscan.io.</a:t>
             </a:r>
           </a:p>
           <a:p>
@@ -1060,7 +1065,7 @@
           <a:p/>
           <a:p>
             <a:r>
-              <a:t>Evidence Tasks: 01a115be-d0ca-77d5-bf90-b98aa4487fec (personal), 01a115c6-b98d-75bd-b5b0-7ab2f85d4ab4 (event workspace), paid 01a115db-7a10-7148-8526-d516924c360c.</a:t>
+              <a:t>Evidence Tasks: 01a115be-d0ca-77d5-bf90-b98aa4487fec (personal), 01a115c6-b98d-75bd-b5b0-7ab2f85d4ab4 and 01a115f9-4653-7647-8b15-c5a3e10f5b30 (event workspace), paid 01a115db-7a10-7148-8526-d516924c360c.</a:t>
             </a:r>
           </a:p>
           <a:p>
@@ -1150,7 +1155,7 @@
           </a:p>
           <a:p>
             <a:r>
-              <a:t>Text work runs on DeepSeek V4.1 Flash, with OpenRouter as fallback. Persona photos use an image model.</a:t>
+              <a:t>Text work runs on DeepSeek V4.1 Flash, with OpenRouter as fallback. Keyframes use Gemini 3.1 Flash Lite Image; clips use xAI Grok Imagine Video 1.5 Lite.</a:t>
             </a:r>
           </a:p>
         </p:txBody>
@@ -1225,7 +1230,7 @@
           </a:p>
           <a:p>
             <a:r>
-              <a:t>Create chains persona, content and media agents. Script and Analyze are single focused agents.</a:t>
+              <a:t>Create chains trend swarm, persona, content, media and video agents. Onboarding is a single focused agent; Script reuses the swarm.</a:t>
             </a:r>
           </a:p>
           <a:p>
@@ -1235,7 +1240,7 @@
           </a:p>
           <a:p>
             <a:r>
-              <a:t>and a merge step dedupes and ranks the trends. A trend without a cited source is dropped.</a:t>
+              <a:t>and a merge step dedupes and ranks the trends. A trend without a search-returned URL is dropped, and a figure survives only if the cited source states it.</a:t>
             </a:r>
           </a:p>
         </p:txBody>
@@ -1315,12 +1320,17 @@
           </a:p>
           <a:p>
             <a:r>
-              <a:t>   Paid Task 01a115db-7a10-7148-8526-d516924c360c reached FundsLocked.</a:t>
-            </a:r>
-          </a:p>
-          <a:p>
-            <a:r>
-              <a:t>3. Result hash: the worker runs the graph, submits the SHA-256 result hash to MPS and completes the Task.</a:t>
+              <a:t>   Paid Task 01a115db-7a10-7148-8526-d516924c360c reached FundsLocked (escrow tx ead8e54bfa59a7a0500ad6fa3914a606861a537b12dd4e612a2dbc89e69e019c).</a:t>
+            </a:r>
+          </a:p>
+          <a:p>
+            <a:r>
+              <a:t>   The first terms (payBy +5 min) expired with no lock; fresh terms with payBy +15 min on the same Task succeeded.</a:t>
+            </a:r>
+          </a:p>
+          <a:p>
+            <a:r>
+              <a:t>3. Result hash: the worker runs the graph, submits the SHA-256 result hash to MPS (tx 02b70f55f770a25e2957c6b09dba25d1789de76518e6fbb27ed0b469dc3041b7) and completes the Task.</a:t>
             </a:r>
           </a:p>
           <a:p>
@@ -1330,7 +1340,7 @@
           </a:p>
           <a:p>
             <a:r>
-              <a:t>   Blockfrost UTxOs and reports the net amount received. Collection is still pending; do not claim it until the tx is confirmed.</a:t>
+              <a:t>   Blockfrost UTxOs and reports the net amount received: 1 tUSDM (1000000 atomic)  ·  Blockfrost UTxOs + Core receipt settled. Collection tx ec5b8dad2a32927b72bd171d0dde69e276fb9485d5b14d6529ea6f4a290d3bc3 (Withdrawn).</a:t>
             </a:r>
           </a:p>
           <a:p>
@@ -1405,7 +1415,7 @@
           <a:lstStyle/>
           <a:p>
             <a:r>
-              <a:t>All IDs here were read back from Sokosumi, MPS or the chain. TODO cells are not done yet and must not be filled with guesses.</a:t>
+              <a:t>All IDs here were read back from Sokosumi, MPS, Blockfrost or the chain. Never replace a value with a guess.</a:t>
             </a:r>
           </a:p>
           <a:p>
@@ -1420,7 +1430,17 @@
           </a:p>
           <a:p>
             <a:r>
-              <a:t>Update the EVIDENCE dict in docs/deck/build_deck.py and re-run it when the collection tx is confirmed.</a:t>
+              <a:t>Result tx: https://preprod.cardanoscan.io/transaction/02b70f55f770a25e2957c6b09dba25d1789de76518e6fbb27ed0b469dc3041b7</a:t>
+            </a:r>
+          </a:p>
+          <a:p>
+            <a:r>
+              <a:t>Trends Task 01a115f9-4653-7647-8b15-c5a3e10f5b30 (event workspace): 8 trends, 7 cited URLs. Event workspace access 01a11580-fdb2-7259-86af-18c58e2ae61e.</a:t>
+            </a:r>
+          </a:p>
+          <a:p>
+            <a:r>
+              <a:t>Full record: docs/paid-proof.json.</a:t>
             </a:r>
           </a:p>
         </p:txBody>
@@ -1505,7 +1525,7 @@
           </a:p>
           <a:p>
             <a:r>
-              <a:t>Pasted comments, metrics and web pages are treated as untrusted data. Analyze returns a measurement plan if no metrics are given.</a:t>
+              <a:t>Pasted text and web pages are treated as untrusted data. Image prompts state safety requirements positively, since negated wording tripped the image safety filter.</a:t>
             </a:r>
           </a:p>
         </p:txBody>
@@ -4663,7 +4683,7 @@
                 </a:solidFill>
                 <a:latin typeface="Segoe UI"/>
               </a:rPr>
-              <a:t>Create  ·  Script  ·  Trends  ·  Analyze</a:t>
+              <a:t>Onboarding  ·  Create  ·  Script  ·  Trends</a:t>
             </a:r>
           </a:p>
         </p:txBody>
@@ -5113,7 +5133,7 @@
                 </a:solidFill>
                 <a:latin typeface="Segoe UI"/>
               </a:rPr>
-              <a:t>  approving the paid Task; seller collection still pending</a:t>
+              <a:t>  approving the paid Task; first terms expired (payBy 5 min), re-quoted at 15 min</a:t>
             </a:r>
           </a:p>
           <a:p>
@@ -5147,7 +5167,7 @@
                 </a:solidFill>
                 <a:latin typeface="Segoe UI"/>
               </a:rPr>
-              <a:t>  no Instagram/TikTok linking in Sokosumi, so Schedule and Engage moved to the roadmap</a:t>
+              <a:t>  no Instagram/TikTok linking in Sokosumi, so Schedule, Engage and Analyze moved to the roadmap</a:t>
             </a:r>
           </a:p>
         </p:txBody>
@@ -5405,7 +5425,7 @@
                 </a:solidFill>
                 <a:latin typeface="Segoe UI"/>
               </a:rPr>
-              <a:t>Schedule + Engage</a:t>
+              <a:t>Schedule, Engage, Analyze</a:t>
             </a:r>
             <a:r>
               <a:rPr sz="1900" b="0">
@@ -5414,7 +5434,7 @@
                 </a:solidFill>
                 <a:latin typeface="Segoe UI"/>
               </a:rPr>
-              <a:t>  in code, dry-run today; go live once Sokosumi can link Instagram/TikTok</a:t>
+              <a:t>  in code, Instagram API dry-run; go live once Sokosumi can link Instagram/TikTok</a:t>
             </a:r>
           </a:p>
           <a:p>
@@ -5439,7 +5459,7 @@
                 </a:solidFill>
                 <a:latin typeface="Segoe UI"/>
               </a:rPr>
-              <a:t>Video</a:t>
+              <a:t>Longer video</a:t>
             </a:r>
             <a:r>
               <a:rPr sz="1900" b="0">
@@ -5448,7 +5468,7 @@
                 </a:solidFill>
                 <a:latin typeface="Segoe UI"/>
               </a:rPr>
-              <a:t>  image-to-video reels and voiceover from the persona photos</a:t>
+              <a:t>  multi-clip ads beyond 20 s, more voices, Create driven by the Onboarding Avatar JSON</a:t>
             </a:r>
           </a:p>
           <a:p>
@@ -6271,7 +6291,7 @@
                 </a:solidFill>
                 <a:latin typeface="Segoe UI"/>
               </a:rPr>
-              <a:t>  persona, scripts, trend research and analytics</a:t>
+              <a:t>  avatar, trend research, scripts and video</a:t>
             </a:r>
           </a:p>
           <a:p>
@@ -6708,7 +6728,7 @@
                 </a:solidFill>
                 <a:latin typeface="Segoe UI"/>
               </a:rPr>
-              <a:t>Create</a:t>
+              <a:t>Onboarding</a:t>
             </a:r>
           </a:p>
         </p:txBody>
@@ -6747,7 +6767,7 @@
                 </a:solidFill>
                 <a:latin typeface="Segoe UI"/>
               </a:rPr>
-              <a:t>AI persona card</a:t>
+              <a:t>Real creator in: interests, values, story, moat</a:t>
             </a:r>
           </a:p>
           <a:p>
@@ -6763,7 +6783,7 @@
                 </a:solidFill>
                 <a:latin typeface="Segoe UI"/>
               </a:rPr>
-              <a:t>Persona photos via image model</a:t>
+              <a:t>Personal virtual avatar</a:t>
             </a:r>
           </a:p>
           <a:p>
@@ -6779,7 +6799,7 @@
                 </a:solidFill>
                 <a:latin typeface="Segoe UI"/>
               </a:rPr>
-              <a:t>8-second reel script</a:t>
+              <a:t>Voice, look, guardrails</a:t>
             </a:r>
           </a:p>
           <a:p>
@@ -6795,7 +6815,7 @@
                 </a:solidFill>
                 <a:latin typeface="Segoe UI"/>
               </a:rPr>
-              <a:t>7-day post plan</a:t>
+              <a:t>Reusable Avatar JSON</a:t>
             </a:r>
           </a:p>
         </p:txBody>
@@ -6920,7 +6940,7 @@
                 </a:solidFill>
                 <a:latin typeface="Segoe UI"/>
               </a:rPr>
-              <a:t>Script</a:t>
+              <a:t>Create</a:t>
             </a:r>
           </a:p>
         </p:txBody>
@@ -6959,7 +6979,7 @@
                 </a:solidFill>
                 <a:latin typeface="Segoe UI"/>
               </a:rPr>
-              <a:t>Trend-based scripts</a:t>
+              <a:t>Trend swarm, persona</a:t>
             </a:r>
           </a:p>
           <a:p>
@@ -6975,7 +6995,7 @@
                 </a:solidFill>
                 <a:latin typeface="Segoe UI"/>
               </a:rPr>
-              <a:t>Reels and TikTok formats</a:t>
+              <a:t>Scene script citing trend URL</a:t>
             </a:r>
           </a:p>
           <a:p>
@@ -6991,7 +7011,7 @@
                 </a:solidFill>
                 <a:latin typeface="Segoe UI"/>
               </a:rPr>
-              <a:t>Hook, beats, shot list</a:t>
+              <a:t>Keyframes + AI video clips</a:t>
             </a:r>
           </a:p>
           <a:p>
@@ -7007,7 +7027,7 @@
                 </a:solidFill>
                 <a:latin typeface="Segoe UI"/>
               </a:rPr>
-              <a:t>Caption + hashtags</a:t>
+              <a:t>9:16 MP4 with voiceover</a:t>
             </a:r>
           </a:p>
         </p:txBody>
@@ -7132,7 +7152,7 @@
                 </a:solidFill>
                 <a:latin typeface="Segoe UI"/>
               </a:rPr>
-              <a:t>Trends</a:t>
+              <a:t>Script</a:t>
             </a:r>
           </a:p>
         </p:txBody>
@@ -7171,7 +7191,7 @@
                 </a:solidFill>
                 <a:latin typeface="Segoe UI"/>
               </a:rPr>
-              <a:t>Swarm of parallel research agents</a:t>
+              <a:t>Trend-based scripts</a:t>
             </a:r>
           </a:p>
           <a:p>
@@ -7187,7 +7207,7 @@
                 </a:solidFill>
                 <a:latin typeface="Segoe UI"/>
               </a:rPr>
-              <a:t>Hot short-video trends</a:t>
+              <a:t>Reels and TikTok formats</a:t>
             </a:r>
           </a:p>
           <a:p>
@@ -7203,7 +7223,7 @@
                 </a:solidFill>
                 <a:latin typeface="Segoe UI"/>
               </a:rPr>
-              <a:t>Cited evidence per trend</a:t>
+              <a:t>Hook, beats, shot list</a:t>
             </a:r>
           </a:p>
           <a:p>
@@ -7219,7 +7239,7 @@
                 </a:solidFill>
                 <a:latin typeface="Segoe UI"/>
               </a:rPr>
-              <a:t>Why it fits the persona</a:t>
+              <a:t>Caption + hashtags</a:t>
             </a:r>
           </a:p>
         </p:txBody>
@@ -7344,7 +7364,7 @@
                 </a:solidFill>
                 <a:latin typeface="Segoe UI"/>
               </a:rPr>
-              <a:t>Analyze</a:t>
+              <a:t>Trends</a:t>
             </a:r>
           </a:p>
         </p:txBody>
@@ -7383,7 +7403,7 @@
                 </a:solidFill>
                 <a:latin typeface="Segoe UI"/>
               </a:rPr>
-              <a:t>Metrics in</a:t>
+              <a:t>Swarm of parallel research agents</a:t>
             </a:r>
           </a:p>
           <a:p>
@@ -7399,7 +7419,7 @@
                 </a:solidFill>
                 <a:latin typeface="Segoe UI"/>
               </a:rPr>
-              <a:t>KPI summary (inputs shown)</a:t>
+              <a:t>Hot short-video trends</a:t>
             </a:r>
           </a:p>
           <a:p>
@@ -7415,7 +7435,7 @@
                 </a:solidFill>
                 <a:latin typeface="Segoe UI"/>
               </a:rPr>
-              <a:t>Hook scorecard</a:t>
+              <a:t>Cited evidence only</a:t>
             </a:r>
           </a:p>
           <a:p>
@@ -7431,7 +7451,7 @@
                 </a:solidFill>
                 <a:latin typeface="Segoe UI"/>
               </a:rPr>
-              <a:t>Next week's plan</a:t>
+              <a:t>URL and number validation</a:t>
             </a:r>
           </a:p>
         </p:txBody>
@@ -7466,7 +7486,7 @@
                 </a:solidFill>
                 <a:latin typeface="Segoe UI"/>
               </a:rPr>
-              <a:t>Roadmap, not offered: Schedule and Engage are in the code in dry-run mode. Sokosumi cannot link Instagram or TikTok accounts yet.</a:t>
+              <a:t>In code, not offered: Schedule, Engage and Analyze (Instagram API dry-run). Sokosumi cannot link Instagram or TikTok accounts yet.</a:t>
             </a:r>
           </a:p>
         </p:txBody>
@@ -8457,7 +8477,7 @@
                 </a:solidFill>
                 <a:latin typeface="Segoe UI"/>
               </a:rPr>
-              <a:t>Script</a:t>
+              <a:t>Onboarding</a:t>
             </a:r>
           </a:p>
           <a:p>
@@ -8469,7 +8489,7 @@
                 </a:solidFill>
                 <a:latin typeface="Segoe UI"/>
               </a:rPr>
-              <a:t>script agent</a:t>
+              <a:t>avatar agent</a:t>
             </a:r>
           </a:p>
         </p:txBody>
@@ -8673,7 +8693,7 @@
                 </a:solidFill>
                 <a:latin typeface="Segoe UI"/>
               </a:rPr>
-              <a:t>Analyze</a:t>
+              <a:t>Script</a:t>
             </a:r>
           </a:p>
           <a:p>
@@ -8685,7 +8705,7 @@
                 </a:solidFill>
                 <a:latin typeface="Segoe UI"/>
               </a:rPr>
-              <a:t>analyst agent</a:t>
+              <a:t>script writer</a:t>
             </a:r>
           </a:p>
         </p:txBody>
@@ -8793,7 +8813,7 @@
                 </a:solidFill>
                 <a:latin typeface="Segoe UI"/>
               </a:rPr>
-              <a:t>persona, content, media</a:t>
+              <a:t>persona, media, video</a:t>
             </a:r>
           </a:p>
         </p:txBody>
@@ -9174,7 +9194,7 @@
                 </a:solidFill>
                 <a:latin typeface="Segoe UI"/>
               </a:rPr>
-              <a:t>Image model</a:t>
+              <a:t>Image + video</a:t>
             </a:r>
           </a:p>
           <a:p>
@@ -9186,7 +9206,7 @@
                 </a:solidFill>
                 <a:latin typeface="Segoe UI"/>
               </a:rPr>
-              <a:t>Create: persona photos</a:t>
+              <a:t>Gemini 3.1 · Grok Imagine</a:t>
             </a:r>
           </a:p>
         </p:txBody>
@@ -9592,7 +9612,7 @@
                 </a:solidFill>
                 <a:latin typeface="Segoe UI"/>
               </a:rPr>
-              <a:t>[stage:create]</a:t>
+              <a:t>[stage:onboarding]</a:t>
             </a:r>
             <a:r>
               <a:rPr sz="1600" b="0">
@@ -9601,7 +9621,7 @@
                 </a:solidFill>
                 <a:latin typeface="Segoe UI"/>
               </a:rPr>
-              <a:t>  persona → content → media (image model)</a:t>
+              <a:t>  real creator → avatar + Avatar JSON</a:t>
             </a:r>
           </a:p>
           <a:p>
@@ -9626,7 +9646,7 @@
                 </a:solidFill>
                 <a:latin typeface="Segoe UI"/>
               </a:rPr>
-              <a:t>[stage:script]</a:t>
+              <a:t>[stage:create]</a:t>
             </a:r>
             <a:r>
               <a:rPr sz="1600" b="0">
@@ -9635,7 +9655,7 @@
                 </a:solidFill>
                 <a:latin typeface="Segoe UI"/>
               </a:rPr>
-              <a:t>  trend-based Reels and TikTok scripts</a:t>
+              <a:t>  swarm → persona → keyframes → AI video → MP4</a:t>
             </a:r>
           </a:p>
           <a:p>
@@ -9660,7 +9680,7 @@
                 </a:solidFill>
                 <a:latin typeface="Segoe UI"/>
               </a:rPr>
-              <a:t>[stage:trends]</a:t>
+              <a:t>[stage:scripts]</a:t>
             </a:r>
             <a:r>
               <a:rPr sz="1600" b="0">
@@ -9669,7 +9689,7 @@
                 </a:solidFill>
                 <a:latin typeface="Segoe UI"/>
               </a:rPr>
-              <a:t>  fan-out to the research swarm</a:t>
+              <a:t>  swarm → trend-based Reels and TikTok scripts</a:t>
             </a:r>
           </a:p>
           <a:p>
@@ -9694,7 +9714,7 @@
                 </a:solidFill>
                 <a:latin typeface="Segoe UI"/>
               </a:rPr>
-              <a:t>[stage:analyze]</a:t>
+              <a:t>[stage:trends]</a:t>
             </a:r>
             <a:r>
               <a:rPr sz="1600" b="0">
@@ -9703,7 +9723,7 @@
                 </a:solidFill>
                 <a:latin typeface="Segoe UI"/>
               </a:rPr>
-              <a:t>  KPIs, hook scores, next week</a:t>
+              <a:t>  Send fan-out to the research swarm</a:t>
             </a:r>
           </a:p>
           <a:p>
@@ -10283,7 +10303,7 @@
                 </a:solidFill>
                 <a:latin typeface="Segoe UI"/>
               </a:rPr>
-              <a:t>Merge: dedupe, rank, keep only cited trends</a:t>
+              <a:t>Merge: validate URLs + numbers, dedupe, rank</a:t>
             </a:r>
           </a:p>
         </p:txBody>
@@ -11017,11 +11037,11 @@
             </a:avLst>
           </a:prstGeom>
           <a:solidFill>
-            <a:srgbClr val="171720"/>
+            <a:srgbClr val="241B3D"/>
           </a:solidFill>
           <a:ln w="12700">
             <a:solidFill>
-              <a:srgbClr val="2A2A38"/>
+              <a:srgbClr val="8B5CF6"/>
             </a:solidFill>
           </a:ln>
           <a:effectLst/>
@@ -11098,12 +11118,10 @@
             </a:avLst>
           </a:prstGeom>
           <a:solidFill>
-            <a:srgbClr val="171720"/>
+            <a:srgbClr val="8B5CF6"/>
           </a:solidFill>
-          <a:ln w="12700">
-            <a:solidFill>
-              <a:srgbClr val="A0A3B1"/>
-            </a:solidFill>
+          <a:ln>
+            <a:noFill/>
           </a:ln>
           <a:effectLst/>
         </p:spPr>
@@ -11133,7 +11151,7 @@
                 </a:solidFill>
                 <a:latin typeface="Segoe UI"/>
               </a:rPr>
-              <a:t>TODO: verify</a:t>
+              <a:t>ResultSubmitted</a:t>
             </a:r>
           </a:p>
         </p:txBody>
@@ -11194,11 +11212,11 @@
             </a:avLst>
           </a:prstGeom>
           <a:solidFill>
-            <a:srgbClr val="171720"/>
+            <a:srgbClr val="241B3D"/>
           </a:solidFill>
           <a:ln w="12700">
             <a:solidFill>
-              <a:srgbClr val="2A2A38"/>
+              <a:srgbClr val="8B5CF6"/>
             </a:solidFill>
           </a:ln>
           <a:effectLst/>
@@ -11253,7 +11271,7 @@
                 </a:solidFill>
                 <a:latin typeface="Segoe UI"/>
               </a:rPr>
-              <a:t>after unlockTime</a:t>
+              <a:t>net 1 tUSDM</a:t>
             </a:r>
           </a:p>
         </p:txBody>
@@ -11275,12 +11293,10 @@
             </a:avLst>
           </a:prstGeom>
           <a:solidFill>
-            <a:srgbClr val="171720"/>
+            <a:srgbClr val="8B5CF6"/>
           </a:solidFill>
-          <a:ln w="12700">
-            <a:solidFill>
-              <a:srgbClr val="A0A3B1"/>
-            </a:solidFill>
+          <a:ln>
+            <a:noFill/>
           </a:ln>
           <a:effectLst/>
         </p:spPr>
@@ -11310,7 +11326,7 @@
                 </a:solidFill>
                 <a:latin typeface="Segoe UI"/>
               </a:rPr>
-              <a:t>Pending</a:t>
+              <a:t>Withdrawn</a:t>
             </a:r>
           </a:p>
         </p:txBody>
@@ -11664,8 +11680,8 @@
           <p:nvPr/>
         </p:nvGraphicFramePr>
         <p:xfrm>
-          <a:off x="777240" y="1463040"/>
-          <a:ext cx="10607040" cy="4389120"/>
+          <a:off x="777240" y="1371600"/>
+          <a:ext cx="10607040" cy="4325112"/>
         </p:xfrm>
         <a:graphic>
           <a:graphicData uri="http://schemas.openxmlformats.org/drawingml/2006/table">
@@ -11677,7 +11693,7 @@
                 <a:gridCol w="2743200"/>
                 <a:gridCol w="7863840"/>
               </a:tblGrid>
-              <a:tr h="438912">
+              <a:tr h="393192">
                 <a:tc>
                   <a:txBody>
                     <a:bodyPr/>
@@ -11763,7 +11779,7 @@
                   </a:tcPr>
                 </a:tc>
               </a:tr>
-              <a:tr h="438912">
+              <a:tr h="393192">
                 <a:tc>
                   <a:txBody>
                     <a:bodyPr/>
@@ -11849,7 +11865,7 @@
                   </a:tcPr>
                 </a:tc>
               </a:tr>
-              <a:tr h="438912">
+              <a:tr h="393192">
                 <a:tc>
                   <a:txBody>
                     <a:bodyPr/>
@@ -11935,7 +11951,7 @@
                   </a:tcPr>
                 </a:tc>
               </a:tr>
-              <a:tr h="438912">
+              <a:tr h="393192">
                 <a:tc>
                   <a:txBody>
                     <a:bodyPr/>
@@ -12022,7 +12038,7 @@
                   </a:tcPr>
                 </a:tc>
               </a:tr>
-              <a:tr h="438912">
+              <a:tr h="393192">
                 <a:tc>
                   <a:txBody>
                     <a:bodyPr/>
@@ -12108,7 +12124,7 @@
                   </a:tcPr>
                 </a:tc>
               </a:tr>
-              <a:tr h="438912">
+              <a:tr h="393192">
                 <a:tc>
                   <a:txBody>
                     <a:bodyPr/>
@@ -12121,7 +12137,7 @@
                           </a:solidFill>
                           <a:latin typeface="Segoe UI"/>
                         </a:rPr>
-                        <a:t>Task, event workspace</a:t>
+                        <a:t>Tasks, event workspace</a:t>
                       </a:r>
                     </a:p>
                   </a:txBody>
@@ -12163,7 +12179,7 @@
                           </a:solidFill>
                           <a:latin typeface="Consolas"/>
                         </a:rPr>
-                        <a:t>01a115c6-b98d-75bd-b5b0-7ab2f85d4ab4  ·  COMPLETED</a:t>
+                        <a:t>Schedule 01a115c6-b98d…  ·  Trends 01a115f9-4653…  ·  COMPLETED</a:t>
                       </a:r>
                     </a:p>
                   </a:txBody>
@@ -12194,7 +12210,7 @@
                   </a:tcPr>
                 </a:tc>
               </a:tr>
-              <a:tr h="438912">
+              <a:tr h="393192">
                 <a:tc>
                   <a:txBody>
                     <a:bodyPr/>
@@ -12249,7 +12265,7 @@
                           </a:solidFill>
                           <a:latin typeface="Consolas"/>
                         </a:rPr>
-                        <a:t>01a115db-7a10-7148-8526-d516924c360c  ·  Escrow FundsLocked, collection pending</a:t>
+                        <a:t>01a115db-7a10-7148-8526-d516924c360c  ·  COMPLETED  ·  collected (Withdrawn)</a:t>
                       </a:r>
                     </a:p>
                   </a:txBody>
@@ -12280,7 +12296,7 @@
                   </a:tcPr>
                 </a:tc>
               </a:tr>
-              <a:tr h="438912">
+              <a:tr h="393192">
                 <a:tc>
                   <a:txBody>
                     <a:bodyPr/>
@@ -12293,7 +12309,7 @@
                           </a:solidFill>
                           <a:latin typeface="Segoe UI"/>
                         </a:rPr>
-                        <a:t>Escrow tx</a:t>
+                        <a:t>Escrow tx (FundsLocked)</a:t>
                       </a:r>
                     </a:p>
                   </a:txBody>
@@ -12334,8 +12350,9 @@
                             <a:srgbClr val="8B5CF6"/>
                           </a:solidFill>
                           <a:latin typeface="Consolas"/>
+                          <a:hlinkClick r:id="rId4"/>
                         </a:rPr>
-                        <a:t>TODO: escrow tx</a:t>
+                        <a:t>ead8e54bfa59a7a0500ad6fa3914a606861a537b12dd4e612a2dbc89e69e019c</a:t>
                       </a:r>
                     </a:p>
                   </a:txBody>
@@ -12366,7 +12383,7 @@
                   </a:tcPr>
                 </a:tc>
               </a:tr>
-              <a:tr h="438912">
+              <a:tr h="393192">
                 <a:tc>
                   <a:txBody>
                     <a:bodyPr/>
@@ -12379,7 +12396,7 @@
                           </a:solidFill>
                           <a:latin typeface="Segoe UI"/>
                         </a:rPr>
-                        <a:t>Collection tx</a:t>
+                        <a:t>Result tx (ResultSubmitted)</a:t>
                       </a:r>
                     </a:p>
                   </a:txBody>
@@ -12420,8 +12437,9 @@
                             <a:srgbClr val="8B5CF6"/>
                           </a:solidFill>
                           <a:latin typeface="Consolas"/>
+                          <a:hlinkClick r:id="rId5"/>
                         </a:rPr>
-                        <a:t>TODO: collection tx</a:t>
+                        <a:t>02b70f55f770a25e2957c6b09dba25d1789de76518e6fbb27ed0b469dc3041b7</a:t>
                       </a:r>
                     </a:p>
                   </a:txBody>
@@ -12452,7 +12470,7 @@
                   </a:tcPr>
                 </a:tc>
               </a:tr>
-              <a:tr h="438912">
+              <a:tr h="393192">
                 <a:tc>
                   <a:txBody>
                     <a:bodyPr/>
@@ -12465,7 +12483,7 @@
                           </a:solidFill>
                           <a:latin typeface="Segoe UI"/>
                         </a:rPr>
-                        <a:t>Net seller receipt</a:t>
+                        <a:t>Collection tx (Withdrawn)</a:t>
                       </a:r>
                     </a:p>
                   </a:txBody>
@@ -12506,8 +12524,9 @@
                             <a:srgbClr val="8B5CF6"/>
                           </a:solidFill>
                           <a:latin typeface="Consolas"/>
+                          <a:hlinkClick r:id="rId6"/>
                         </a:rPr>
-                        <a:t>TODO: net tUSDM received (settlement.mjs)</a:t>
+                        <a:t>ec5b8dad2a32927b72bd171d0dde69e276fb9485d5b14d6529ea6f4a290d3bc3</a:t>
                       </a:r>
                     </a:p>
                   </a:txBody>
@@ -12534,6 +12553,92 @@
                     </a:lnL>
                     <a:solidFill>
                       <a:srgbClr val="171720"/>
+                    </a:solidFill>
+                  </a:tcPr>
+                </a:tc>
+              </a:tr>
+              <a:tr h="393192">
+                <a:tc>
+                  <a:txBody>
+                    <a:bodyPr/>
+                    <a:lstStyle/>
+                    <a:p>
+                      <a:r>
+                        <a:rPr sz="1300" b="1">
+                          <a:solidFill>
+                            <a:srgbClr val="FFFFFF"/>
+                          </a:solidFill>
+                          <a:latin typeface="Segoe UI"/>
+                        </a:rPr>
+                        <a:t>Net seller receipt</a:t>
+                      </a:r>
+                    </a:p>
+                  </a:txBody>
+                  <a:tcPr marL="109728" anchor="ctr">
+                    <a:lnB w="12700">
+                      <a:solidFill>
+                        <a:srgbClr val="2A2A38"/>
+                      </a:solidFill>
+                    </a:lnB>
+                    <a:lnT w="12700">
+                      <a:solidFill>
+                        <a:srgbClr val="2A2A38"/>
+                      </a:solidFill>
+                    </a:lnT>
+                    <a:lnR w="12700">
+                      <a:solidFill>
+                        <a:srgbClr val="2A2A38"/>
+                      </a:solidFill>
+                    </a:lnR>
+                    <a:lnL w="12700">
+                      <a:solidFill>
+                        <a:srgbClr val="2A2A38"/>
+                      </a:solidFill>
+                    </a:lnL>
+                    <a:solidFill>
+                      <a:srgbClr val="0B0B10"/>
+                    </a:solidFill>
+                  </a:tcPr>
+                </a:tc>
+                <a:tc>
+                  <a:txBody>
+                    <a:bodyPr/>
+                    <a:lstStyle/>
+                    <a:p>
+                      <a:r>
+                        <a:rPr sz="1200" b="0">
+                          <a:solidFill>
+                            <a:srgbClr val="A0A3B1"/>
+                          </a:solidFill>
+                          <a:latin typeface="Consolas"/>
+                        </a:rPr>
+                        <a:t>1 tUSDM (1000000 atomic)  ·  Blockfrost UTxOs + Core receipt settled</a:t>
+                      </a:r>
+                    </a:p>
+                  </a:txBody>
+                  <a:tcPr marL="109728" anchor="ctr">
+                    <a:lnB w="12700">
+                      <a:solidFill>
+                        <a:srgbClr val="2A2A38"/>
+                      </a:solidFill>
+                    </a:lnB>
+                    <a:lnT w="12700">
+                      <a:solidFill>
+                        <a:srgbClr val="2A2A38"/>
+                      </a:solidFill>
+                    </a:lnT>
+                    <a:lnR w="12700">
+                      <a:solidFill>
+                        <a:srgbClr val="2A2A38"/>
+                      </a:solidFill>
+                    </a:lnR>
+                    <a:lnL w="12700">
+                      <a:solidFill>
+                        <a:srgbClr val="2A2A38"/>
+                      </a:solidFill>
+                    </a:lnL>
+                    <a:solidFill>
+                      <a:srgbClr val="0B0B10"/>
                     </a:solidFill>
                   </a:tcPr>
                 </a:tc>

</xml_diff>